<commit_message>
feat: add IAC extension system post with supporting image and style updates
</commit_message>
<xml_diff>
--- a/templates/PostImage.pptx
+++ b/templates/PostImage.pptx
@@ -6,6 +6,8 @@
   </p:sldMasterIdLst>
   <p:sldIdLst>
     <p:sldId id="256" r:id="rId2"/>
+    <p:sldId id="257" r:id="rId3"/>
+    <p:sldId id="258" r:id="rId4"/>
   </p:sldIdLst>
   <p:sldSz cx="12192000" cy="6858000"/>
   <p:notesSz cx="6858000" cy="9144000"/>
@@ -254,7 +256,7 @@
           <a:p>
             <a:fld id="{A7B99496-28B4-4F48-9C90-51DE3F753911}" type="datetimeFigureOut">
               <a:rPr lang="en-US" smtClean="0"/>
-              <a:t>12/3/25</a:t>
+              <a:t>3/2/26</a:t>
             </a:fld>
             <a:endParaRPr lang="en-US"/>
           </a:p>
@@ -427,7 +429,7 @@
           <a:p>
             <a:fld id="{A7B99496-28B4-4F48-9C90-51DE3F753911}" type="datetimeFigureOut">
               <a:rPr lang="en-US" smtClean="0"/>
-              <a:t>12/3/25</a:t>
+              <a:t>3/2/26</a:t>
             </a:fld>
             <a:endParaRPr lang="en-US"/>
           </a:p>
@@ -610,7 +612,7 @@
           <a:p>
             <a:fld id="{A7B99496-28B4-4F48-9C90-51DE3F753911}" type="datetimeFigureOut">
               <a:rPr lang="en-US" smtClean="0"/>
-              <a:t>12/3/25</a:t>
+              <a:t>3/2/26</a:t>
             </a:fld>
             <a:endParaRPr lang="en-US"/>
           </a:p>
@@ -783,7 +785,7 @@
           <a:p>
             <a:fld id="{A7B99496-28B4-4F48-9C90-51DE3F753911}" type="datetimeFigureOut">
               <a:rPr lang="en-US" smtClean="0"/>
-              <a:t>12/3/25</a:t>
+              <a:t>3/2/26</a:t>
             </a:fld>
             <a:endParaRPr lang="en-US"/>
           </a:p>
@@ -1032,7 +1034,7 @@
           <a:p>
             <a:fld id="{A7B99496-28B4-4F48-9C90-51DE3F753911}" type="datetimeFigureOut">
               <a:rPr lang="en-US" smtClean="0"/>
-              <a:t>12/3/25</a:t>
+              <a:t>3/2/26</a:t>
             </a:fld>
             <a:endParaRPr lang="en-US"/>
           </a:p>
@@ -1267,7 +1269,7 @@
           <a:p>
             <a:fld id="{A7B99496-28B4-4F48-9C90-51DE3F753911}" type="datetimeFigureOut">
               <a:rPr lang="en-US" smtClean="0"/>
-              <a:t>12/3/25</a:t>
+              <a:t>3/2/26</a:t>
             </a:fld>
             <a:endParaRPr lang="en-US"/>
           </a:p>
@@ -1637,7 +1639,7 @@
           <a:p>
             <a:fld id="{A7B99496-28B4-4F48-9C90-51DE3F753911}" type="datetimeFigureOut">
               <a:rPr lang="en-US" smtClean="0"/>
-              <a:t>12/3/25</a:t>
+              <a:t>3/2/26</a:t>
             </a:fld>
             <a:endParaRPr lang="en-US"/>
           </a:p>
@@ -1758,7 +1760,7 @@
           <a:p>
             <a:fld id="{A7B99496-28B4-4F48-9C90-51DE3F753911}" type="datetimeFigureOut">
               <a:rPr lang="en-US" smtClean="0"/>
-              <a:t>12/3/25</a:t>
+              <a:t>3/2/26</a:t>
             </a:fld>
             <a:endParaRPr lang="en-US"/>
           </a:p>
@@ -1856,7 +1858,7 @@
           <a:p>
             <a:fld id="{A7B99496-28B4-4F48-9C90-51DE3F753911}" type="datetimeFigureOut">
               <a:rPr lang="en-US" smtClean="0"/>
-              <a:t>12/3/25</a:t>
+              <a:t>3/2/26</a:t>
             </a:fld>
             <a:endParaRPr lang="en-US"/>
           </a:p>
@@ -2136,7 +2138,7 @@
           <a:p>
             <a:fld id="{A7B99496-28B4-4F48-9C90-51DE3F753911}" type="datetimeFigureOut">
               <a:rPr lang="en-US" smtClean="0"/>
-              <a:t>12/3/25</a:t>
+              <a:t>3/2/26</a:t>
             </a:fld>
             <a:endParaRPr lang="en-US"/>
           </a:p>
@@ -2396,7 +2398,7 @@
           <a:p>
             <a:fld id="{A7B99496-28B4-4F48-9C90-51DE3F753911}" type="datetimeFigureOut">
               <a:rPr lang="en-US" smtClean="0"/>
-              <a:t>12/3/25</a:t>
+              <a:t>3/2/26</a:t>
             </a:fld>
             <a:endParaRPr lang="en-US"/>
           </a:p>
@@ -2612,7 +2614,7 @@
           <a:p>
             <a:fld id="{A7B99496-28B4-4F48-9C90-51DE3F753911}" type="datetimeFigureOut">
               <a:rPr lang="en-US" smtClean="0"/>
-              <a:t>12/3/25</a:t>
+              <a:t>3/2/26</a:t>
             </a:fld>
             <a:endParaRPr lang="en-US"/>
           </a:p>
@@ -3246,6 +3248,738 @@
 </p:sld>
 </file>
 
+<file path=ppt/slides/slide2.xml><?xml version="1.0" encoding="utf-8"?>
+<p:sld xmlns:a="http://schemas.openxmlformats.org/drawingml/2006/main" xmlns:r="http://schemas.openxmlformats.org/officeDocument/2006/relationships" xmlns:p="http://schemas.openxmlformats.org/presentationml/2006/main">
+  <p:cSld>
+    <p:bg>
+      <p:bgPr>
+        <a:gradFill flip="none" rotWithShape="1">
+          <a:gsLst>
+            <a:gs pos="67000">
+              <a:srgbClr val="203445"/>
+            </a:gs>
+            <a:gs pos="11000">
+              <a:srgbClr val="5187B5"/>
+            </a:gs>
+          </a:gsLst>
+          <a:path path="circle">
+            <a:fillToRect l="100000" t="100000"/>
+          </a:path>
+          <a:tileRect r="-100000" b="-100000"/>
+        </a:gradFill>
+        <a:effectLst/>
+      </p:bgPr>
+    </p:bg>
+    <p:spTree>
+      <p:nvGrpSpPr>
+        <p:cNvPr id="1" name="">
+          <a:extLst>
+            <a:ext uri="{FF2B5EF4-FFF2-40B4-BE49-F238E27FC236}">
+              <a16:creationId xmlns:a16="http://schemas.microsoft.com/office/drawing/2014/main" id="{862CF5FF-E63E-1F88-A253-D5314E0D491B}"/>
+            </a:ext>
+          </a:extLst>
+        </p:cNvPr>
+        <p:cNvGrpSpPr/>
+        <p:nvPr/>
+      </p:nvGrpSpPr>
+      <p:grpSpPr>
+        <a:xfrm>
+          <a:off x="0" y="0"/>
+          <a:ext cx="0" cy="0"/>
+          <a:chOff x="0" y="0"/>
+          <a:chExt cx="0" cy="0"/>
+        </a:xfrm>
+      </p:grpSpPr>
+      <p:sp>
+        <p:nvSpPr>
+          <p:cNvPr id="2" name="Title 1">
+            <a:extLst>
+              <a:ext uri="{FF2B5EF4-FFF2-40B4-BE49-F238E27FC236}">
+                <a16:creationId xmlns:a16="http://schemas.microsoft.com/office/drawing/2014/main" id="{67D73FB5-A707-9A9D-A044-B40BBAED8BE4}"/>
+              </a:ext>
+            </a:extLst>
+          </p:cNvPr>
+          <p:cNvSpPr>
+            <a:spLocks noGrp="1"/>
+          </p:cNvSpPr>
+          <p:nvPr>
+            <p:ph type="ctrTitle"/>
+          </p:nvPr>
+        </p:nvSpPr>
+        <p:spPr>
+          <a:xfrm>
+            <a:off x="998899" y="3000453"/>
+            <a:ext cx="10194202" cy="857094"/>
+          </a:xfrm>
+          <a:noFill/>
+        </p:spPr>
+        <p:txBody>
+          <a:bodyPr wrap="none">
+            <a:spAutoFit/>
+          </a:bodyPr>
+          <a:lstStyle/>
+          <a:p>
+            <a:r>
+              <a:rPr lang="en-US" sz="5400" b="1" dirty="0">
+                <a:solidFill>
+                  <a:schemeClr val="bg1"/>
+                </a:solidFill>
+                <a:latin typeface="Avenir Book" panose="02000503020000020003" pitchFamily="2" charset="0"/>
+                <a:cs typeface="Al Nile" pitchFamily="2" charset="-78"/>
+              </a:rPr>
+              <a:t>IAC Prototype Extension System</a:t>
+            </a:r>
+          </a:p>
+        </p:txBody>
+      </p:sp>
+      <p:sp>
+        <p:nvSpPr>
+          <p:cNvPr id="38" name="Title 1">
+            <a:extLst>
+              <a:ext uri="{FF2B5EF4-FFF2-40B4-BE49-F238E27FC236}">
+                <a16:creationId xmlns:a16="http://schemas.microsoft.com/office/drawing/2014/main" id="{167F8182-AAF4-E41D-BE17-36D63C7D4ABB}"/>
+              </a:ext>
+            </a:extLst>
+          </p:cNvPr>
+          <p:cNvSpPr txBox="1">
+            <a:spLocks/>
+          </p:cNvSpPr>
+          <p:nvPr/>
+        </p:nvSpPr>
+        <p:spPr>
+          <a:xfrm>
+            <a:off x="1010369" y="5086748"/>
+            <a:ext cx="10171259" cy="679828"/>
+          </a:xfrm>
+          <a:prstGeom prst="rect">
+            <a:avLst/>
+          </a:prstGeom>
+        </p:spPr>
+        <p:txBody>
+          <a:bodyPr vert="horz" lIns="91440" tIns="45720" rIns="91440" bIns="45720" rtlCol="0" anchor="b">
+            <a:noAutofit/>
+          </a:bodyPr>
+          <a:lstStyle>
+            <a:lvl1pPr algn="l" defTabSz="914400" rtl="0" eaLnBrk="1" latinLnBrk="0" hangingPunct="1">
+              <a:lnSpc>
+                <a:spcPct val="90000"/>
+              </a:lnSpc>
+              <a:spcBef>
+                <a:spcPct val="0"/>
+              </a:spcBef>
+              <a:buNone/>
+              <a:defRPr sz="8800" kern="1200">
+                <a:solidFill>
+                  <a:schemeClr val="tx1"/>
+                </a:solidFill>
+                <a:latin typeface="+mj-lt"/>
+                <a:ea typeface="+mj-ea"/>
+                <a:cs typeface="+mj-cs"/>
+              </a:defRPr>
+            </a:lvl1pPr>
+          </a:lstStyle>
+          <a:p>
+            <a:endParaRPr lang="en-US" sz="2400" b="1" dirty="0">
+              <a:solidFill>
+                <a:srgbClr val="085758"/>
+              </a:solidFill>
+              <a:latin typeface="Avenir Book" panose="02000503020000020003" pitchFamily="2" charset="0"/>
+              <a:cs typeface="Al Nile" pitchFamily="2" charset="-78"/>
+            </a:endParaRPr>
+          </a:p>
+        </p:txBody>
+      </p:sp>
+      <p:grpSp>
+        <p:nvGrpSpPr>
+          <p:cNvPr id="11" name="Group 10">
+            <a:extLst>
+              <a:ext uri="{FF2B5EF4-FFF2-40B4-BE49-F238E27FC236}">
+                <a16:creationId xmlns:a16="http://schemas.microsoft.com/office/drawing/2014/main" id="{E86F9822-4126-103A-478F-D30F374A258A}"/>
+              </a:ext>
+            </a:extLst>
+          </p:cNvPr>
+          <p:cNvGrpSpPr/>
+          <p:nvPr/>
+        </p:nvGrpSpPr>
+        <p:grpSpPr>
+          <a:xfrm>
+            <a:off x="998899" y="2045938"/>
+            <a:ext cx="3552121" cy="679829"/>
+            <a:chOff x="887655" y="969277"/>
+            <a:chExt cx="3552121" cy="679829"/>
+          </a:xfrm>
+        </p:grpSpPr>
+        <p:sp>
+          <p:nvSpPr>
+            <p:cNvPr id="39" name="Title 1">
+              <a:extLst>
+                <a:ext uri="{FF2B5EF4-FFF2-40B4-BE49-F238E27FC236}">
+                  <a16:creationId xmlns:a16="http://schemas.microsoft.com/office/drawing/2014/main" id="{D7A297E3-295C-F1D1-B767-1513B9DCFA80}"/>
+                </a:ext>
+              </a:extLst>
+            </p:cNvPr>
+            <p:cNvSpPr txBox="1">
+              <a:spLocks/>
+            </p:cNvSpPr>
+            <p:nvPr/>
+          </p:nvSpPr>
+          <p:spPr>
+            <a:xfrm>
+              <a:off x="1567484" y="1091424"/>
+              <a:ext cx="2872292" cy="466991"/>
+            </a:xfrm>
+            <a:prstGeom prst="rect">
+              <a:avLst/>
+            </a:prstGeom>
+          </p:spPr>
+          <p:txBody>
+            <a:bodyPr vert="horz" lIns="91440" tIns="45720" rIns="91440" bIns="45720" rtlCol="0" anchor="b">
+              <a:noAutofit/>
+            </a:bodyPr>
+            <a:lstStyle>
+              <a:lvl1pPr algn="l" defTabSz="914400" rtl="0" eaLnBrk="1" latinLnBrk="0" hangingPunct="1">
+                <a:lnSpc>
+                  <a:spcPct val="90000"/>
+                </a:lnSpc>
+                <a:spcBef>
+                  <a:spcPct val="0"/>
+                </a:spcBef>
+                <a:buNone/>
+                <a:defRPr sz="8800" kern="1200">
+                  <a:solidFill>
+                    <a:schemeClr val="tx1"/>
+                  </a:solidFill>
+                  <a:latin typeface="+mj-lt"/>
+                  <a:ea typeface="+mj-ea"/>
+                  <a:cs typeface="+mj-cs"/>
+                </a:defRPr>
+              </a:lvl1pPr>
+            </a:lstStyle>
+            <a:p>
+              <a:r>
+                <a:rPr lang="en-US" sz="2400" b="1" dirty="0">
+                  <a:solidFill>
+                    <a:schemeClr val="bg1">
+                      <a:lumMod val="85000"/>
+                    </a:schemeClr>
+                  </a:solidFill>
+                  <a:latin typeface="Arial" panose="020B0604020202020204" pitchFamily="34" charset="0"/>
+                  <a:cs typeface="Arial" panose="020B0604020202020204" pitchFamily="34" charset="0"/>
+                </a:rPr>
+                <a:t>OWASP </a:t>
+              </a:r>
+              <a:r>
+                <a:rPr lang="en-US" sz="2400" dirty="0">
+                  <a:solidFill>
+                    <a:schemeClr val="bg1">
+                      <a:lumMod val="85000"/>
+                    </a:schemeClr>
+                  </a:solidFill>
+                  <a:latin typeface="Arial" panose="020B0604020202020204" pitchFamily="34" charset="0"/>
+                  <a:cs typeface="Arial" panose="020B0604020202020204" pitchFamily="34" charset="0"/>
+                </a:rPr>
+                <a:t>HACTU8</a:t>
+              </a:r>
+            </a:p>
+          </p:txBody>
+        </p:sp>
+        <p:pic>
+          <p:nvPicPr>
+            <p:cNvPr id="9" name="Picture 2" descr="IAC Logo">
+              <a:extLst>
+                <a:ext uri="{FF2B5EF4-FFF2-40B4-BE49-F238E27FC236}">
+                  <a16:creationId xmlns:a16="http://schemas.microsoft.com/office/drawing/2014/main" id="{F9F11530-2DB4-3296-486A-ACDBA8753454}"/>
+                </a:ext>
+              </a:extLst>
+            </p:cNvPr>
+            <p:cNvPicPr>
+              <a:picLocks noChangeAspect="1" noChangeArrowheads="1"/>
+            </p:cNvPicPr>
+            <p:nvPr/>
+          </p:nvPicPr>
+          <p:blipFill>
+            <a:blip r:embed="rId2">
+              <a:extLst>
+                <a:ext uri="{28A0092B-C50C-407E-A947-70E740481C1C}">
+                  <a14:useLocalDpi xmlns:a14="http://schemas.microsoft.com/office/drawing/2010/main" val="0"/>
+                </a:ext>
+              </a:extLst>
+            </a:blip>
+            <a:srcRect/>
+            <a:stretch>
+              <a:fillRect/>
+            </a:stretch>
+          </p:blipFill>
+          <p:spPr bwMode="auto">
+            <a:xfrm>
+              <a:off x="887655" y="969277"/>
+              <a:ext cx="679829" cy="679829"/>
+            </a:xfrm>
+            <a:prstGeom prst="rect">
+              <a:avLst/>
+            </a:prstGeom>
+            <a:noFill/>
+            <a:extLst>
+              <a:ext uri="{909E8E84-426E-40DD-AFC4-6F175D3DCCD1}">
+                <a14:hiddenFill xmlns:a14="http://schemas.microsoft.com/office/drawing/2010/main">
+                  <a:solidFill>
+                    <a:srgbClr val="FFFFFF"/>
+                  </a:solidFill>
+                </a14:hiddenFill>
+              </a:ext>
+            </a:extLst>
+          </p:spPr>
+        </p:pic>
+      </p:grpSp>
+    </p:spTree>
+    <p:extLst>
+      <p:ext uri="{BB962C8B-B14F-4D97-AF65-F5344CB8AC3E}">
+        <p14:creationId xmlns:p14="http://schemas.microsoft.com/office/powerpoint/2010/main" val="2618155648"/>
+      </p:ext>
+    </p:extLst>
+  </p:cSld>
+  <p:clrMapOvr>
+    <a:masterClrMapping/>
+  </p:clrMapOvr>
+  <p:transition>
+    <p:fade/>
+  </p:transition>
+</p:sld>
+</file>
+
+<file path=ppt/slides/slide3.xml><?xml version="1.0" encoding="utf-8"?>
+<p:sld xmlns:a="http://schemas.openxmlformats.org/drawingml/2006/main" xmlns:r="http://schemas.openxmlformats.org/officeDocument/2006/relationships" xmlns:p="http://schemas.openxmlformats.org/presentationml/2006/main">
+  <p:cSld>
+    <p:spTree>
+      <p:nvGrpSpPr>
+        <p:cNvPr id="1" name=""/>
+        <p:cNvGrpSpPr/>
+        <p:nvPr/>
+      </p:nvGrpSpPr>
+      <p:grpSpPr>
+        <a:xfrm>
+          <a:off x="0" y="0"/>
+          <a:ext cx="0" cy="0"/>
+          <a:chOff x="0" y="0"/>
+          <a:chExt cx="0" cy="0"/>
+        </a:xfrm>
+      </p:grpSpPr>
+      <p:sp>
+        <p:nvSpPr>
+          <p:cNvPr id="2" name="Title 1">
+            <a:extLst>
+              <a:ext uri="{FF2B5EF4-FFF2-40B4-BE49-F238E27FC236}">
+                <a16:creationId xmlns:a16="http://schemas.microsoft.com/office/drawing/2014/main" id="{8FD177F4-8173-FA72-E9B3-806B3D043E53}"/>
+              </a:ext>
+            </a:extLst>
+          </p:cNvPr>
+          <p:cNvSpPr>
+            <a:spLocks noGrp="1"/>
+          </p:cNvSpPr>
+          <p:nvPr>
+            <p:ph type="title"/>
+          </p:nvPr>
+        </p:nvSpPr>
+        <p:spPr/>
+        <p:txBody>
+          <a:bodyPr/>
+          <a:lstStyle/>
+          <a:p>
+            <a:endParaRPr lang="en-US"/>
+          </a:p>
+        </p:txBody>
+      </p:sp>
+      <p:sp>
+        <p:nvSpPr>
+          <p:cNvPr id="3" name="Content Placeholder 2">
+            <a:extLst>
+              <a:ext uri="{FF2B5EF4-FFF2-40B4-BE49-F238E27FC236}">
+                <a16:creationId xmlns:a16="http://schemas.microsoft.com/office/drawing/2014/main" id="{6BD1BE90-11FA-3F78-8398-7D53CF9808C6}"/>
+              </a:ext>
+            </a:extLst>
+          </p:cNvPr>
+          <p:cNvSpPr>
+            <a:spLocks noGrp="1"/>
+          </p:cNvSpPr>
+          <p:nvPr>
+            <p:ph idx="1"/>
+          </p:nvPr>
+        </p:nvSpPr>
+        <p:spPr>
+          <a:xfrm>
+            <a:off x="838200" y="1825625"/>
+            <a:ext cx="5143323" cy="894491"/>
+          </a:xfrm>
+        </p:spPr>
+        <p:txBody>
+          <a:bodyPr/>
+          <a:lstStyle/>
+          <a:p>
+            <a:endParaRPr lang="en-US" dirty="0"/>
+          </a:p>
+        </p:txBody>
+      </p:sp>
+      <p:sp>
+        <p:nvSpPr>
+          <p:cNvPr id="4" name="Rectangle 1">
+            <a:extLst>
+              <a:ext uri="{FF2B5EF4-FFF2-40B4-BE49-F238E27FC236}">
+                <a16:creationId xmlns:a16="http://schemas.microsoft.com/office/drawing/2014/main" id="{16CFA37B-0BC6-8A59-DD2A-4856B394AA04}"/>
+              </a:ext>
+            </a:extLst>
+          </p:cNvPr>
+          <p:cNvSpPr>
+            <a:spLocks noChangeArrowheads="1"/>
+          </p:cNvSpPr>
+          <p:nvPr/>
+        </p:nvSpPr>
+        <p:spPr bwMode="auto">
+          <a:xfrm>
+            <a:off x="0" y="-36632136"/>
+            <a:ext cx="5963273" cy="74158763"/>
+          </a:xfrm>
+          <a:prstGeom prst="rect">
+            <a:avLst/>
+          </a:prstGeom>
+          <a:noFill/>
+          <a:ln>
+            <a:noFill/>
+          </a:ln>
+          <a:effectLst/>
+          <a:extLst>
+            <a:ext uri="{909E8E84-426E-40DD-AFC4-6F175D3DCCD1}">
+              <a14:hiddenFill xmlns:a14="http://schemas.microsoft.com/office/drawing/2010/main">
+                <a:solidFill>
+                  <a:schemeClr val="accent1"/>
+                </a:solidFill>
+              </a14:hiddenFill>
+            </a:ext>
+            <a:ext uri="{91240B29-F687-4F45-9708-019B960494DF}">
+              <a14:hiddenLine xmlns:a14="http://schemas.microsoft.com/office/drawing/2010/main" w="9525">
+                <a:solidFill>
+                  <a:schemeClr val="tx1"/>
+                </a:solidFill>
+                <a:miter lim="800000"/>
+                <a:headEnd/>
+                <a:tailEnd/>
+              </a14:hiddenLine>
+            </a:ext>
+            <a:ext uri="{AF507438-7753-43E0-B8FC-AC1667EBCBE1}">
+              <a14:hiddenEffects xmlns:a14="http://schemas.microsoft.com/office/drawing/2010/main">
+                <a:effectLst>
+                  <a:outerShdw dist="35921" dir="2700000" algn="ctr" rotWithShape="0">
+                    <a:schemeClr val="bg2"/>
+                  </a:outerShdw>
+                </a:effectLst>
+              </a14:hiddenEffects>
+            </a:ext>
+          </a:extLst>
+        </p:spPr>
+        <p:txBody>
+          <a:bodyPr vert="horz" wrap="square" lIns="91440" tIns="45720" rIns="91440" bIns="45720" numCol="1" anchor="ctr" anchorCtr="0" compatLnSpc="1">
+            <a:prstTxWarp prst="textNoShape">
+              <a:avLst/>
+            </a:prstTxWarp>
+            <a:spAutoFit/>
+          </a:bodyPr>
+          <a:lstStyle>
+            <a:lvl1pPr eaLnBrk="0" fontAlgn="base" hangingPunct="0">
+              <a:spcBef>
+                <a:spcPct val="0"/>
+              </a:spcBef>
+              <a:spcAft>
+                <a:spcPct val="0"/>
+              </a:spcAft>
+              <a:defRPr>
+                <a:solidFill>
+                  <a:schemeClr val="tx1"/>
+                </a:solidFill>
+                <a:latin typeface="Arial" panose="020B0604020202020204" pitchFamily="34" charset="0"/>
+              </a:defRPr>
+            </a:lvl1pPr>
+            <a:lvl2pPr eaLnBrk="0" fontAlgn="base" hangingPunct="0">
+              <a:spcBef>
+                <a:spcPct val="0"/>
+              </a:spcBef>
+              <a:spcAft>
+                <a:spcPct val="0"/>
+              </a:spcAft>
+              <a:defRPr>
+                <a:solidFill>
+                  <a:schemeClr val="tx1"/>
+                </a:solidFill>
+                <a:latin typeface="Arial" panose="020B0604020202020204" pitchFamily="34" charset="0"/>
+              </a:defRPr>
+            </a:lvl2pPr>
+            <a:lvl3pPr eaLnBrk="0" fontAlgn="base" hangingPunct="0">
+              <a:spcBef>
+                <a:spcPct val="0"/>
+              </a:spcBef>
+              <a:spcAft>
+                <a:spcPct val="0"/>
+              </a:spcAft>
+              <a:defRPr>
+                <a:solidFill>
+                  <a:schemeClr val="tx1"/>
+                </a:solidFill>
+                <a:latin typeface="Arial" panose="020B0604020202020204" pitchFamily="34" charset="0"/>
+              </a:defRPr>
+            </a:lvl3pPr>
+            <a:lvl4pPr eaLnBrk="0" fontAlgn="base" hangingPunct="0">
+              <a:spcBef>
+                <a:spcPct val="0"/>
+              </a:spcBef>
+              <a:spcAft>
+                <a:spcPct val="0"/>
+              </a:spcAft>
+              <a:defRPr>
+                <a:solidFill>
+                  <a:schemeClr val="tx1"/>
+                </a:solidFill>
+                <a:latin typeface="Arial" panose="020B0604020202020204" pitchFamily="34" charset="0"/>
+              </a:defRPr>
+            </a:lvl4pPr>
+            <a:lvl5pPr eaLnBrk="0" fontAlgn="base" hangingPunct="0">
+              <a:spcBef>
+                <a:spcPct val="0"/>
+              </a:spcBef>
+              <a:spcAft>
+                <a:spcPct val="0"/>
+              </a:spcAft>
+              <a:defRPr>
+                <a:solidFill>
+                  <a:schemeClr val="tx1"/>
+                </a:solidFill>
+                <a:latin typeface="Arial" panose="020B0604020202020204" pitchFamily="34" charset="0"/>
+              </a:defRPr>
+            </a:lvl5pPr>
+            <a:lvl6pPr eaLnBrk="0" fontAlgn="base" hangingPunct="0">
+              <a:spcBef>
+                <a:spcPct val="0"/>
+              </a:spcBef>
+              <a:spcAft>
+                <a:spcPct val="0"/>
+              </a:spcAft>
+              <a:defRPr>
+                <a:solidFill>
+                  <a:schemeClr val="tx1"/>
+                </a:solidFill>
+                <a:latin typeface="Arial" panose="020B0604020202020204" pitchFamily="34" charset="0"/>
+              </a:defRPr>
+            </a:lvl6pPr>
+            <a:lvl7pPr eaLnBrk="0" fontAlgn="base" hangingPunct="0">
+              <a:spcBef>
+                <a:spcPct val="0"/>
+              </a:spcBef>
+              <a:spcAft>
+                <a:spcPct val="0"/>
+              </a:spcAft>
+              <a:defRPr>
+                <a:solidFill>
+                  <a:schemeClr val="tx1"/>
+                </a:solidFill>
+                <a:latin typeface="Arial" panose="020B0604020202020204" pitchFamily="34" charset="0"/>
+              </a:defRPr>
+            </a:lvl7pPr>
+            <a:lvl8pPr eaLnBrk="0" fontAlgn="base" hangingPunct="0">
+              <a:spcBef>
+                <a:spcPct val="0"/>
+              </a:spcBef>
+              <a:spcAft>
+                <a:spcPct val="0"/>
+              </a:spcAft>
+              <a:defRPr>
+                <a:solidFill>
+                  <a:schemeClr val="tx1"/>
+                </a:solidFill>
+                <a:latin typeface="Arial" panose="020B0604020202020204" pitchFamily="34" charset="0"/>
+              </a:defRPr>
+            </a:lvl8pPr>
+            <a:lvl9pPr eaLnBrk="0" fontAlgn="base" hangingPunct="0">
+              <a:spcBef>
+                <a:spcPct val="0"/>
+              </a:spcBef>
+              <a:spcAft>
+                <a:spcPct val="0"/>
+              </a:spcAft>
+              <a:defRPr>
+                <a:solidFill>
+                  <a:schemeClr val="tx1"/>
+                </a:solidFill>
+                <a:latin typeface="Arial" panose="020B0604020202020204" pitchFamily="34" charset="0"/>
+              </a:defRPr>
+            </a:lvl9pPr>
+          </a:lstStyle>
+          <a:p>
+            <a:pPr marL="0" marR="0" lvl="0" indent="0" algn="l" defTabSz="914400" rtl="0" eaLnBrk="0" fontAlgn="base" latinLnBrk="0" hangingPunct="0">
+              <a:lnSpc>
+                <a:spcPct val="100000"/>
+              </a:lnSpc>
+              <a:spcBef>
+                <a:spcPct val="0"/>
+              </a:spcBef>
+              <a:spcAft>
+                <a:spcPct val="0"/>
+              </a:spcAft>
+              <a:buClrTx/>
+              <a:buSzTx/>
+              <a:buFontTx/>
+              <a:buNone/>
+              <a:tabLst/>
+            </a:pPr>
+            <a:r>
+              <a:rPr kumimoji="0" lang="en-US" altLang="en-US" sz="1800" b="0" i="0" u="none" strike="noStrike" cap="none" normalizeH="0" baseline="0">
+                <a:ln>
+                  <a:noFill/>
+                </a:ln>
+                <a:solidFill>
+                  <a:schemeClr val="tx1"/>
+                </a:solidFill>
+                <a:effectLst/>
+                <a:latin typeface="Arial" panose="020B0604020202020204" pitchFamily="34" charset="0"/>
+              </a:rPr>
+              <a:t>  </a:t>
+            </a:r>
+            <a:r>
+              <a:rPr kumimoji="0" lang="en-US" altLang="en-US" sz="96000" b="0" i="0" u="none" strike="noStrike" cap="none" normalizeH="0" baseline="0">
+                <a:ln>
+                  <a:noFill/>
+                </a:ln>
+                <a:solidFill>
+                  <a:schemeClr val="tx1"/>
+                </a:solidFill>
+                <a:effectLst/>
+                <a:latin typeface="Arial" panose="020B0604020202020204" pitchFamily="34" charset="0"/>
+              </a:rPr>
+              <a:t>     </a:t>
+            </a:r>
+            <a:r>
+              <a:rPr kumimoji="0" lang="en-US" altLang="en-US" sz="1300" b="1" i="0" u="none" strike="noStrike" cap="none" normalizeH="0" baseline="0">
+                <a:ln>
+                  <a:noFill/>
+                </a:ln>
+                <a:solidFill>
+                  <a:srgbClr val="FFFFFF"/>
+                </a:solidFill>
+                <a:effectLst/>
+                <a:latin typeface="system-ui"/>
+              </a:rPr>
+              <a:t>OWASP</a:t>
+            </a:r>
+            <a:r>
+              <a:rPr kumimoji="0" lang="en-US" altLang="en-US" sz="1300" b="0" i="0" u="none" strike="noStrike" cap="none" normalizeH="0" baseline="0">
+                <a:ln>
+                  <a:noFill/>
+                </a:ln>
+                <a:solidFill>
+                  <a:srgbClr val="FFFFFF"/>
+                </a:solidFill>
+                <a:effectLst/>
+                <a:latin typeface="system-ui"/>
+              </a:rPr>
+              <a:t> HACTU8</a:t>
+            </a:r>
+            <a:br>
+              <a:rPr kumimoji="0" lang="en-US" altLang="en-US" sz="1300" b="0" i="0" u="none" strike="noStrike" cap="none" normalizeH="0" baseline="0">
+                <a:ln>
+                  <a:noFill/>
+                </a:ln>
+                <a:solidFill>
+                  <a:srgbClr val="FFFFFF"/>
+                </a:solidFill>
+                <a:effectLst/>
+                <a:latin typeface="system-ui"/>
+              </a:rPr>
+            </a:br>
+            <a:r>
+              <a:rPr kumimoji="0" lang="en-US" altLang="en-US" sz="1300" b="0" i="0" u="none" strike="noStrike" cap="none" normalizeH="0" baseline="0">
+                <a:ln>
+                  <a:noFill/>
+                </a:ln>
+                <a:solidFill>
+                  <a:srgbClr val="FFFFFF"/>
+                </a:solidFill>
+                <a:effectLst/>
+                <a:latin typeface="system-ui"/>
+              </a:rPr>
+              <a:t>Intelligence Assurance Center</a:t>
+            </a:r>
+            <a:endParaRPr kumimoji="0" lang="en-US" altLang="en-US" sz="1800" b="0" i="0" u="none" strike="noStrike" cap="none" normalizeH="0" baseline="0">
+              <a:ln>
+                <a:noFill/>
+              </a:ln>
+              <a:solidFill>
+                <a:schemeClr val="tx1"/>
+              </a:solidFill>
+              <a:effectLst/>
+              <a:latin typeface="Arial" panose="020B0604020202020204" pitchFamily="34" charset="0"/>
+            </a:endParaRPr>
+          </a:p>
+        </p:txBody>
+      </p:sp>
+      <p:pic>
+        <p:nvPicPr>
+          <p:cNvPr id="2050" name="Picture 2" descr="IAC Logo">
+            <a:extLst>
+              <a:ext uri="{FF2B5EF4-FFF2-40B4-BE49-F238E27FC236}">
+                <a16:creationId xmlns:a16="http://schemas.microsoft.com/office/drawing/2014/main" id="{008E86AE-E4F3-4C8B-A34F-774F3FF396B9}"/>
+              </a:ext>
+            </a:extLst>
+          </p:cNvPr>
+          <p:cNvPicPr>
+            <a:picLocks noChangeAspect="1" noChangeArrowheads="1"/>
+          </p:cNvPicPr>
+          <p:nvPr/>
+        </p:nvPicPr>
+        <p:blipFill>
+          <a:blip r:embed="rId2">
+            <a:extLst>
+              <a:ext uri="{28A0092B-C50C-407E-A947-70E740481C1C}">
+                <a14:useLocalDpi xmlns:a14="http://schemas.microsoft.com/office/drawing/2010/main" val="0"/>
+              </a:ext>
+            </a:extLst>
+          </a:blip>
+          <a:srcRect/>
+          <a:stretch>
+            <a:fillRect/>
+          </a:stretch>
+        </p:blipFill>
+        <p:spPr bwMode="auto">
+          <a:xfrm>
+            <a:off x="127000" y="-7413625"/>
+            <a:ext cx="894491" cy="894491"/>
+          </a:xfrm>
+          <a:prstGeom prst="rect">
+            <a:avLst/>
+          </a:prstGeom>
+          <a:noFill/>
+          <a:extLst>
+            <a:ext uri="{909E8E84-426E-40DD-AFC4-6F175D3DCCD1}">
+              <a14:hiddenFill xmlns:a14="http://schemas.microsoft.com/office/drawing/2010/main">
+                <a:solidFill>
+                  <a:srgbClr val="FFFFFF"/>
+                </a:solidFill>
+              </a14:hiddenFill>
+            </a:ext>
+          </a:extLst>
+        </p:spPr>
+      </p:pic>
+    </p:spTree>
+    <p:extLst>
+      <p:ext uri="{BB962C8B-B14F-4D97-AF65-F5344CB8AC3E}">
+        <p14:creationId xmlns:p14="http://schemas.microsoft.com/office/powerpoint/2010/main" val="502412726"/>
+      </p:ext>
+    </p:extLst>
+  </p:cSld>
+  <p:clrMapOvr>
+    <a:masterClrMapping/>
+  </p:clrMapOvr>
+  <p:transition>
+    <p:fade/>
+  </p:transition>
+</p:sld>
+</file>
+
 <file path=ppt/theme/theme1.xml><?xml version="1.0" encoding="utf-8"?>
 <a:theme xmlns:a="http://schemas.openxmlformats.org/drawingml/2006/main" name="Office Theme">
   <a:themeElements>

</xml_diff>

<commit_message>
fix: update PostImage.pptx and remove temporary file
</commit_message>
<xml_diff>
--- a/templates/PostImage.pptx
+++ b/templates/PostImage.pptx
@@ -3253,20 +3253,9 @@
   <p:cSld>
     <p:bg>
       <p:bgPr>
-        <a:gradFill flip="none" rotWithShape="1">
-          <a:gsLst>
-            <a:gs pos="67000">
-              <a:srgbClr val="203445"/>
-            </a:gs>
-            <a:gs pos="11000">
-              <a:srgbClr val="5187B5"/>
-            </a:gs>
-          </a:gsLst>
-          <a:path path="circle">
-            <a:fillToRect l="100000" t="100000"/>
-          </a:path>
-          <a:tileRect r="-100000" b="-100000"/>
-        </a:gradFill>
+        <a:solidFill>
+          <a:srgbClr val="203445"/>
+        </a:solidFill>
         <a:effectLst/>
       </p:bgPr>
     </p:bg>

</xml_diff>